<commit_message>
Fix Diapositiva 6: show both boundary conditions per BVP case
Each of the three case cards was only displaying the second boundary
condition (e.g. y(π/2)=0), omitting the shared y(0)=0 that the spoken
guión already accounted for. For a second-order equation a BVP needs
two conditions, so showing only one was visually incomplete/misleading
even though the underlying math was correct. Each card now shows both
conditions in the equation image, with the algebraic consequence
(⟹ ...) as a short line below it.
</commit_message>
<xml_diff>
--- a/sesion9/Sesion9_Teoria_Preliminar.pptx
+++ b/sesion9/Sesion9_Teoria_Preliminar.pptx
@@ -7376,11 +7376,11 @@
         <p:spPr>
           <a:xfrm>
             <a:off x="548640" y="2194560"/>
-            <a:ext cx="3515258" cy="1417320"/>
+            <a:ext cx="3515258" cy="1600200"/>
           </a:xfrm>
           <a:prstGeom prst="roundRect">
             <a:avLst>
-              <a:gd name="adj" fmla="val 5161"/>
+              <a:gd name="adj" fmla="val 4571"/>
             </a:avLst>
           </a:prstGeom>
           <a:solidFill>
@@ -7403,7 +7403,7 @@
         <p:spPr>
           <a:xfrm>
             <a:off x="685800" y="2331720"/>
-            <a:ext cx="3240938" cy="320040"/>
+            <a:ext cx="3240938" cy="274320"/>
           </a:xfrm>
           <a:prstGeom prst="rect">
             <a:avLst/>
@@ -7449,8 +7449,8 @@
         </p:blipFill>
         <p:spPr>
           <a:xfrm>
-            <a:off x="685800" y="2932697"/>
-            <a:ext cx="3240938" cy="306807"/>
+            <a:off x="685800" y="2668667"/>
+            <a:ext cx="3240938" cy="423385"/>
           </a:xfrm>
           <a:prstGeom prst="rect">
             <a:avLst/>
@@ -7459,18 +7459,60 @@
       </p:pic>
       <p:sp>
         <p:nvSpPr>
-          <p:cNvPr id="8" name="Shape 4"/>
+          <p:cNvPr id="8" name="Text 4"/>
+          <p:cNvSpPr/>
+          <p:nvPr/>
+        </p:nvSpPr>
+        <p:spPr>
+          <a:xfrm>
+            <a:off x="685800" y="3154680"/>
+            <a:ext cx="3240938" cy="548640"/>
+          </a:xfrm>
+          <a:prstGeom prst="rect">
+            <a:avLst/>
+          </a:prstGeom>
+          <a:noFill/>
+          <a:ln/>
+        </p:spPr>
+        <p:txBody>
+          <a:bodyPr wrap="square" lIns="0" tIns="0" rIns="0" bIns="0" rtlCol="0" anchor="t"/>
+          <a:lstStyle/>
+          <a:p>
+            <a:pPr algn="ctr" indent="0" marL="0">
+              <a:lnSpc>
+                <a:spcPct val="110000"/>
+              </a:lnSpc>
+              <a:buNone/>
+            </a:pPr>
+            <a:r>
+              <a:rPr lang="en-US" sz="1150" dirty="0">
+                <a:solidFill>
+                  <a:srgbClr val="CBD5E1"/>
+                </a:solidFill>
+                <a:latin typeface="Calibri" pitchFamily="34" charset="0"/>
+                <a:ea typeface="Calibri" pitchFamily="34" charset="-122"/>
+                <a:cs typeface="Calibri" pitchFamily="34" charset="-120"/>
+              </a:rPr>
+              <a:t>⟹ C₂sin(2π)=0 → cualquier C₂</a:t>
+            </a:r>
+            <a:endParaRPr lang="en-US" sz="1150" dirty="0"/>
+          </a:p>
+        </p:txBody>
+      </p:sp>
+      <p:sp>
+        <p:nvSpPr>
+          <p:cNvPr id="9" name="Shape 5"/>
           <p:cNvSpPr/>
           <p:nvPr/>
         </p:nvSpPr>
         <p:spPr>
           <a:xfrm>
             <a:off x="4338218" y="2194560"/>
-            <a:ext cx="3515258" cy="1417320"/>
+            <a:ext cx="3515258" cy="1600200"/>
           </a:xfrm>
           <a:prstGeom prst="roundRect">
             <a:avLst>
-              <a:gd name="adj" fmla="val 5161"/>
+              <a:gd name="adj" fmla="val 4571"/>
             </a:avLst>
           </a:prstGeom>
           <a:solidFill>
@@ -7486,14 +7528,14 @@
       </p:sp>
       <p:sp>
         <p:nvSpPr>
-          <p:cNvPr id="9" name="Text 5"/>
+          <p:cNvPr id="10" name="Text 6"/>
           <p:cNvSpPr/>
           <p:nvPr/>
         </p:nvSpPr>
         <p:spPr>
           <a:xfrm>
             <a:off x="4475378" y="2331720"/>
-            <a:ext cx="3240938" cy="320040"/>
+            <a:ext cx="3240938" cy="274320"/>
           </a:xfrm>
           <a:prstGeom prst="rect">
             <a:avLst/>
@@ -7525,7 +7567,7 @@
       </p:sp>
       <p:pic>
         <p:nvPicPr>
-          <p:cNvPr id="10" name="Image 2" descr="build/eq/bvp_case2.png">    </p:cNvPr>
+          <p:cNvPr id="11" name="Image 2" descr="build/eq/bvp_case2.png">    </p:cNvPr>
           <p:cNvPicPr>
             <a:picLocks noChangeAspect="1"/>
           </p:cNvPicPr>
@@ -7539,8 +7581,8 @@
         </p:blipFill>
         <p:spPr>
           <a:xfrm>
-            <a:off x="4475378" y="2932697"/>
-            <a:ext cx="3240938" cy="306807"/>
+            <a:off x="4475378" y="2668667"/>
+            <a:ext cx="3240938" cy="423385"/>
           </a:xfrm>
           <a:prstGeom prst="rect">
             <a:avLst/>
@@ -7549,18 +7591,60 @@
       </p:pic>
       <p:sp>
         <p:nvSpPr>
-          <p:cNvPr id="11" name="Shape 6"/>
+          <p:cNvPr id="12" name="Text 7"/>
+          <p:cNvSpPr/>
+          <p:nvPr/>
+        </p:nvSpPr>
+        <p:spPr>
+          <a:xfrm>
+            <a:off x="4475378" y="3154680"/>
+            <a:ext cx="3240938" cy="548640"/>
+          </a:xfrm>
+          <a:prstGeom prst="rect">
+            <a:avLst/>
+          </a:prstGeom>
+          <a:noFill/>
+          <a:ln/>
+        </p:spPr>
+        <p:txBody>
+          <a:bodyPr wrap="square" lIns="0" tIns="0" rIns="0" bIns="0" rtlCol="0" anchor="t"/>
+          <a:lstStyle/>
+          <a:p>
+            <a:pPr algn="ctr" indent="0" marL="0">
+              <a:lnSpc>
+                <a:spcPct val="110000"/>
+              </a:lnSpc>
+              <a:buNone/>
+            </a:pPr>
+            <a:r>
+              <a:rPr lang="en-US" sz="1150" dirty="0">
+                <a:solidFill>
+                  <a:srgbClr val="CBD5E1"/>
+                </a:solidFill>
+                <a:latin typeface="Calibri" pitchFamily="34" charset="0"/>
+                <a:ea typeface="Calibri" pitchFamily="34" charset="-122"/>
+                <a:cs typeface="Calibri" pitchFamily="34" charset="-120"/>
+              </a:rPr>
+              <a:t>⟹ C₂sin(2π)=1 → imposible</a:t>
+            </a:r>
+            <a:endParaRPr lang="en-US" sz="1150" dirty="0"/>
+          </a:p>
+        </p:txBody>
+      </p:sp>
+      <p:sp>
+        <p:nvSpPr>
+          <p:cNvPr id="13" name="Shape 8"/>
           <p:cNvSpPr/>
           <p:nvPr/>
         </p:nvSpPr>
         <p:spPr>
           <a:xfrm>
             <a:off x="8127797" y="2194560"/>
-            <a:ext cx="3515258" cy="1417320"/>
+            <a:ext cx="3515258" cy="1600200"/>
           </a:xfrm>
           <a:prstGeom prst="roundRect">
             <a:avLst>
-              <a:gd name="adj" fmla="val 5161"/>
+              <a:gd name="adj" fmla="val 4571"/>
             </a:avLst>
           </a:prstGeom>
           <a:solidFill>
@@ -7576,14 +7660,14 @@
       </p:sp>
       <p:sp>
         <p:nvSpPr>
-          <p:cNvPr id="12" name="Text 7"/>
+          <p:cNvPr id="14" name="Text 9"/>
           <p:cNvSpPr/>
           <p:nvPr/>
         </p:nvSpPr>
         <p:spPr>
           <a:xfrm>
             <a:off x="8264957" y="2331720"/>
-            <a:ext cx="3240938" cy="320040"/>
+            <a:ext cx="3240938" cy="274320"/>
           </a:xfrm>
           <a:prstGeom prst="rect">
             <a:avLst/>
@@ -7615,7 +7699,7 @@
       </p:sp>
       <p:pic>
         <p:nvPicPr>
-          <p:cNvPr id="13" name="Image 3" descr="build/eq/bvp_case3.png">    </p:cNvPr>
+          <p:cNvPr id="15" name="Image 3" descr="build/eq/bvp_case3.png">    </p:cNvPr>
           <p:cNvPicPr>
             <a:picLocks noChangeAspect="1"/>
           </p:cNvPicPr>
@@ -7629,8 +7713,8 @@
         </p:blipFill>
         <p:spPr>
           <a:xfrm>
-            <a:off x="8264957" y="2938239"/>
-            <a:ext cx="3240938" cy="295722"/>
+            <a:off x="8264957" y="2668667"/>
+            <a:ext cx="3240938" cy="423385"/>
           </a:xfrm>
           <a:prstGeom prst="rect">
             <a:avLst/>
@@ -7639,18 +7723,60 @@
       </p:pic>
       <p:sp>
         <p:nvSpPr>
-          <p:cNvPr id="14" name="Shape 8"/>
-          <p:cNvSpPr/>
-          <p:nvPr/>
-        </p:nvSpPr>
-        <p:spPr>
-          <a:xfrm>
-            <a:off x="548640" y="3886200"/>
-            <a:ext cx="11094415" cy="2514600"/>
+          <p:cNvPr id="16" name="Text 10"/>
+          <p:cNvSpPr/>
+          <p:nvPr/>
+        </p:nvSpPr>
+        <p:spPr>
+          <a:xfrm>
+            <a:off x="8264957" y="3154680"/>
+            <a:ext cx="3240938" cy="548640"/>
+          </a:xfrm>
+          <a:prstGeom prst="rect">
+            <a:avLst/>
+          </a:prstGeom>
+          <a:noFill/>
+          <a:ln/>
+        </p:spPr>
+        <p:txBody>
+          <a:bodyPr wrap="square" lIns="0" tIns="0" rIns="0" bIns="0" rtlCol="0" anchor="t"/>
+          <a:lstStyle/>
+          <a:p>
+            <a:pPr algn="ctr" indent="0" marL="0">
+              <a:lnSpc>
+                <a:spcPct val="110000"/>
+              </a:lnSpc>
+              <a:buNone/>
+            </a:pPr>
+            <a:r>
+              <a:rPr lang="en-US" sz="1150" dirty="0">
+                <a:solidFill>
+                  <a:srgbClr val="CBD5E1"/>
+                </a:solidFill>
+                <a:latin typeface="Calibri" pitchFamily="34" charset="0"/>
+                <a:ea typeface="Calibri" pitchFamily="34" charset="-122"/>
+                <a:cs typeface="Calibri" pitchFamily="34" charset="-120"/>
+              </a:rPr>
+              <a:t>⟹ C₂sin(π/2)=0 → C₂=0</a:t>
+            </a:r>
+            <a:endParaRPr lang="en-US" sz="1150" dirty="0"/>
+          </a:p>
+        </p:txBody>
+      </p:sp>
+      <p:sp>
+        <p:nvSpPr>
+          <p:cNvPr id="17" name="Shape 11"/>
+          <p:cNvSpPr/>
+          <p:nvPr/>
+        </p:nvSpPr>
+        <p:spPr>
+          <a:xfrm>
+            <a:off x="548640" y="4069080"/>
+            <a:ext cx="11094415" cy="2331720"/>
           </a:xfrm>
           <a:prstGeom prst="roundRect">
             <a:avLst>
-              <a:gd name="adj" fmla="val 3636"/>
+              <a:gd name="adj" fmla="val 3922"/>
             </a:avLst>
           </a:prstGeom>
           <a:solidFill>
@@ -7661,7 +7787,7 @@
       </p:sp>
       <p:pic>
         <p:nvPicPr>
-          <p:cNvPr id="15" name="Image 4" descr="build/img/bvp_family.png">    </p:cNvPr>
+          <p:cNvPr id="18" name="Image 4" descr="build/img/bvp_family.png">    </p:cNvPr>
           <p:cNvPicPr>
             <a:picLocks noChangeAspect="1"/>
           </p:cNvPicPr>
@@ -7675,8 +7801,8 @@
         </p:blipFill>
         <p:spPr>
           <a:xfrm>
-            <a:off x="4614745" y="4023360"/>
-            <a:ext cx="2962204" cy="1874520"/>
+            <a:off x="4759243" y="4206240"/>
+            <a:ext cx="2673209" cy="1691640"/>
           </a:xfrm>
           <a:prstGeom prst="rect">
             <a:avLst/>
@@ -7685,7 +7811,7 @@
       </p:pic>
       <p:sp>
         <p:nvSpPr>
-          <p:cNvPr id="16" name="Text 9"/>
+          <p:cNvPr id="19" name="Text 12"/>
           <p:cNvSpPr/>
           <p:nvPr/>
         </p:nvSpPr>
@@ -7727,7 +7853,7 @@
       </p:sp>
       <p:sp>
         <p:nvSpPr>
-          <p:cNvPr id="17" name="Text 10"/>
+          <p:cNvPr id="20" name="Text 13"/>
           <p:cNvSpPr/>
           <p:nvPr/>
         </p:nvSpPr>
@@ -7766,7 +7892,7 @@
       </p:sp>
       <p:sp>
         <p:nvSpPr>
-          <p:cNvPr id="18" name="Text 11"/>
+          <p:cNvPr id="21" name="Text 14"/>
           <p:cNvSpPr/>
           <p:nvPr/>
         </p:nvSpPr>

</xml_diff>

<commit_message>
Fix Sesión 9 Diapositiva 7: define 'homogénea' and flag terminology collision with Sesión 7
Diapositiva 7 used "ecuación homogénea" (right-hand side g(x)=0) as if
already established, but Sesión 9 never defines it, and the term was
previously used in Sesión 7 for a completely unrelated concept
(dy/dx=f(y/x), solved via y=vx). Add an explicit vocabulary-pause
callout on Diapositiva 7 that defines the new meaning and states plainly
that it has no relation to Sesión 7's usage, plus a short forward-pointer
in Diapositiva 2 where the old meaning is first mentioned in this guión.

Co-Authored-By: Claude Sonnet 5 <noreply@anthropic.com>
Claude-Session: https://claude.ai/code/session_01YYoLTm5E5BxGfUsceBVgwN
</commit_message>
<xml_diff>
--- a/sesion9/Sesion9_Teoria_Preliminar.pptx
+++ b/sesion9/Sesion9_Teoria_Preliminar.pptx
@@ -8048,11 +8048,80 @@
         <p:spPr>
           <a:xfrm>
             <a:off x="548640" y="1691640"/>
-            <a:ext cx="11094415" cy="1371600"/>
+            <a:ext cx="11094415" cy="960120"/>
           </a:xfrm>
           <a:prstGeom prst="roundRect">
             <a:avLst>
-              <a:gd name="adj" fmla="val 5333"/>
+              <a:gd name="adj" fmla="val 7619"/>
+            </a:avLst>
+          </a:prstGeom>
+          <a:solidFill>
+            <a:srgbClr val="3A2A0E"/>
+          </a:solidFill>
+          <a:ln w="12700">
+            <a:solidFill>
+              <a:srgbClr val="F59E0B"/>
+            </a:solidFill>
+            <a:prstDash val="solid"/>
+          </a:ln>
+        </p:spPr>
+      </p:sp>
+      <p:sp>
+        <p:nvSpPr>
+          <p:cNvPr id="5" name="Text 3"/>
+          <p:cNvSpPr/>
+          <p:nvPr/>
+        </p:nvSpPr>
+        <p:spPr>
+          <a:xfrm>
+            <a:off x="777240" y="1691640"/>
+            <a:ext cx="10637215" cy="960120"/>
+          </a:xfrm>
+          <a:prstGeom prst="rect">
+            <a:avLst/>
+          </a:prstGeom>
+          <a:noFill/>
+          <a:ln/>
+        </p:spPr>
+        <p:txBody>
+          <a:bodyPr wrap="square" lIns="0" tIns="0" rIns="0" bIns="0" rtlCol="0" anchor="ctr"/>
+          <a:lstStyle/>
+          <a:p>
+            <a:pPr algn="l" indent="0" marL="0">
+              <a:lnSpc>
+                <a:spcPct val="115000"/>
+              </a:lnSpc>
+              <a:buNone/>
+            </a:pPr>
+            <a:r>
+              <a:rPr lang="en-US" sz="1350" b="1" dirty="0">
+                <a:solidFill>
+                  <a:srgbClr val="FBBF24"/>
+                </a:solidFill>
+                <a:latin typeface="Calibri" pitchFamily="34" charset="0"/>
+                <a:ea typeface="Calibri" pitchFamily="34" charset="-122"/>
+                <a:cs typeface="Calibri" pitchFamily="34" charset="-120"/>
+              </a:rPr>
+              <a:t>⚠ 'Homogénea' cambia de significado aquí. En la Sesión 7 era dy/dx=f(y/x), resuelta con y=vx. Desde ahora significa g(x)=0 — el lado derecho es cero. Dos ideas distintas, mismo nombre: no las confundan.</a:t>
+            </a:r>
+            <a:endParaRPr lang="en-US" sz="1350" dirty="0"/>
+          </a:p>
+        </p:txBody>
+      </p:sp>
+      <p:sp>
+        <p:nvSpPr>
+          <p:cNvPr id="6" name="Shape 4"/>
+          <p:cNvSpPr/>
+          <p:nvPr/>
+        </p:nvSpPr>
+        <p:spPr>
+          <a:xfrm>
+            <a:off x="548640" y="2788920"/>
+            <a:ext cx="11094415" cy="1097280"/>
+          </a:xfrm>
+          <a:prstGeom prst="roundRect">
+            <a:avLst>
+              <a:gd name="adj" fmla="val 6667"/>
             </a:avLst>
           </a:prstGeom>
           <a:solidFill>
@@ -8068,7 +8137,7 @@
       </p:sp>
       <p:pic>
         <p:nvPicPr>
-          <p:cNvPr id="5" name="Image 0" descr="build/eq/superposition_homog.png">    </p:cNvPr>
+          <p:cNvPr id="7" name="Image 0" descr="build/eq/superposition_homog.png">    </p:cNvPr>
           <p:cNvPicPr>
             <a:picLocks noChangeAspect="1"/>
           </p:cNvPicPr>
@@ -8082,8 +8151,8 @@
         </p:blipFill>
         <p:spPr>
           <a:xfrm>
-            <a:off x="822960" y="1864985"/>
-            <a:ext cx="10545775" cy="1024909"/>
+            <a:off x="1861935" y="2926080"/>
+            <a:ext cx="8467825" cy="822960"/>
           </a:xfrm>
           <a:prstGeom prst="rect">
             <a:avLst/>
@@ -8092,14 +8161,14 @@
       </p:pic>
       <p:sp>
         <p:nvSpPr>
-          <p:cNvPr id="6" name="Text 3"/>
-          <p:cNvSpPr/>
-          <p:nvPr/>
-        </p:nvSpPr>
-        <p:spPr>
-          <a:xfrm>
-            <a:off x="548640" y="3337560"/>
-            <a:ext cx="11094415" cy="822960"/>
+          <p:cNvPr id="8" name="Text 5"/>
+          <p:cNvSpPr/>
+          <p:nvPr/>
+        </p:nvSpPr>
+        <p:spPr>
+          <a:xfrm>
+            <a:off x="548640" y="4023360"/>
+            <a:ext cx="11094415" cy="731520"/>
           </a:xfrm>
           <a:prstGeom prst="rect">
             <a:avLst/>
@@ -8118,7 +8187,7 @@
               <a:buNone/>
             </a:pPr>
             <a:r>
-              <a:rPr lang="en-US" sz="1500" dirty="0">
+              <a:rPr lang="en-US" sz="1450" dirty="0">
                 <a:solidFill>
                   <a:srgbClr val="CBD5E1"/>
                 </a:solidFill>
@@ -8126,26 +8195,26 @@
                 <a:ea typeface="Calibri" pitchFamily="34" charset="-122"/>
                 <a:cs typeface="Calibri" pitchFamily="34" charset="-120"/>
               </a:rPr>
-              <a:t>Si y₁, y₂, …, yₖ son soluciones de la MISMA ecuación homogénea, entonces cualquier combinación lineal de ellas también es solución. Pueden verificarlo sustituyendo directamente.</a:t>
-            </a:r>
-            <a:endParaRPr lang="en-US" sz="1500" dirty="0"/>
-          </a:p>
-        </p:txBody>
-      </p:sp>
-      <p:sp>
-        <p:nvSpPr>
-          <p:cNvPr id="7" name="Shape 4"/>
-          <p:cNvSpPr/>
-          <p:nvPr/>
-        </p:nvSpPr>
-        <p:spPr>
-          <a:xfrm>
-            <a:off x="548640" y="4343400"/>
-            <a:ext cx="11094415" cy="777240"/>
+              <a:t>Si y₁, y₂, …, yₖ son soluciones de la MISMA ecuación homogénea (en este nuevo sentido), entonces cualquier combinación lineal de ellas también es solución. Pueden verificarlo sustituyendo directamente.</a:t>
+            </a:r>
+            <a:endParaRPr lang="en-US" sz="1450" dirty="0"/>
+          </a:p>
+        </p:txBody>
+      </p:sp>
+      <p:sp>
+        <p:nvSpPr>
+          <p:cNvPr id="9" name="Shape 6"/>
+          <p:cNvSpPr/>
+          <p:nvPr/>
+        </p:nvSpPr>
+        <p:spPr>
+          <a:xfrm>
+            <a:off x="548640" y="4892040"/>
+            <a:ext cx="11094415" cy="731520"/>
           </a:xfrm>
           <a:prstGeom prst="roundRect">
             <a:avLst>
-              <a:gd name="adj" fmla="val 9412"/>
+              <a:gd name="adj" fmla="val 10000"/>
             </a:avLst>
           </a:prstGeom>
           <a:solidFill>
@@ -8161,14 +8230,14 @@
       </p:sp>
       <p:sp>
         <p:nvSpPr>
-          <p:cNvPr id="8" name="Text 5"/>
-          <p:cNvSpPr/>
-          <p:nvPr/>
-        </p:nvSpPr>
-        <p:spPr>
-          <a:xfrm>
-            <a:off x="777240" y="4343400"/>
-            <a:ext cx="10637215" cy="777240"/>
+          <p:cNvPr id="10" name="Text 7"/>
+          <p:cNvSpPr/>
+          <p:nvPr/>
+        </p:nvSpPr>
+        <p:spPr>
+          <a:xfrm>
+            <a:off x="777240" y="4892040"/>
+            <a:ext cx="10637215" cy="731520"/>
           </a:xfrm>
           <a:prstGeom prst="rect">
             <a:avLst/>
@@ -8187,7 +8256,7 @@
               <a:buNone/>
             </a:pPr>
             <a:r>
-              <a:rPr lang="en-US" sz="1400" b="1" dirty="0">
+              <a:rPr lang="en-US" sz="1350" b="1" dirty="0">
                 <a:solidFill>
                   <a:srgbClr val="34D399"/>
                 </a:solidFill>
@@ -8197,13 +8266,13 @@
               </a:rPr>
               <a:t>Esta es la razón por la que, en la Sesión 10, nunca vamos a buscar 'la' solución — vamos a buscar varias soluciones simples y combinarlas.</a:t>
             </a:r>
-            <a:endParaRPr lang="en-US" sz="1400" dirty="0"/>
-          </a:p>
-        </p:txBody>
-      </p:sp>
-      <p:sp>
-        <p:nvSpPr>
-          <p:cNvPr id="9" name="Text 6"/>
+            <a:endParaRPr lang="en-US" sz="1350" dirty="0"/>
+          </a:p>
+        </p:txBody>
+      </p:sp>
+      <p:sp>
+        <p:nvSpPr>
+          <p:cNvPr id="11" name="Text 8"/>
           <p:cNvSpPr/>
           <p:nvPr/>
         </p:nvSpPr>
@@ -8242,7 +8311,7 @@
       </p:sp>
       <p:sp>
         <p:nvSpPr>
-          <p:cNvPr id="10" name="Text 7"/>
+          <p:cNvPr id="12" name="Text 9"/>
           <p:cNvSpPr/>
           <p:nvPr/>
         </p:nvSpPr>

</xml_diff>

<commit_message>
Move 'homogénea' vocabulary-pause to Diapositiva 3 where g(x) is introduced
The definition fits more naturally right where g(x) appears in the PVI
equation (Diapositiva 3) than at the superposition slide (Diapositiva 7),
which was just recycling it. Moved the amber warning callout and its
spoken narration accordingly; Diapositiva 7 now just references the
earlier definition with a short callback. Diapositiva 2's forward-pointer
updated to point one slide ahead instead of "later today".

Co-Authored-By: Claude Sonnet 5 <noreply@anthropic.com>
Claude-Session: https://claude.ai/code/session_01YYoLTm5E5BxGfUsceBVgwN
</commit_message>
<xml_diff>
--- a/sesion9/Sesion9_Teoria_Preliminar.pptx
+++ b/sesion9/Sesion9_Teoria_Preliminar.pptx
@@ -6146,12 +6146,12 @@
         </p:nvSpPr>
         <p:spPr>
           <a:xfrm>
-            <a:off x="548640" y="1645920"/>
-            <a:ext cx="11094415" cy="1051560"/>
+            <a:off x="548640" y="1600200"/>
+            <a:ext cx="11094415" cy="960120"/>
           </a:xfrm>
           <a:prstGeom prst="roundRect">
             <a:avLst>
-              <a:gd name="adj" fmla="val 8696"/>
+              <a:gd name="adj" fmla="val 9524"/>
             </a:avLst>
           </a:prstGeom>
           <a:solidFill>
@@ -6176,8 +6176,8 @@
         </p:blipFill>
         <p:spPr>
           <a:xfrm>
-            <a:off x="2386994" y="1783080"/>
-            <a:ext cx="7417707" cy="777240"/>
+            <a:off x="2823330" y="1737360"/>
+            <a:ext cx="6545036" cy="685800"/>
           </a:xfrm>
           <a:prstGeom prst="rect">
             <a:avLst/>
@@ -6192,12 +6192,81 @@
         </p:nvSpPr>
         <p:spPr>
           <a:xfrm>
-            <a:off x="548640" y="2880360"/>
-            <a:ext cx="11094415" cy="1051560"/>
+            <a:off x="548640" y="2651760"/>
+            <a:ext cx="11094415" cy="914400"/>
           </a:xfrm>
           <a:prstGeom prst="roundRect">
             <a:avLst>
-              <a:gd name="adj" fmla="val 8696"/>
+              <a:gd name="adj" fmla="val 8000"/>
+            </a:avLst>
+          </a:prstGeom>
+          <a:solidFill>
+            <a:srgbClr val="3A2A0E"/>
+          </a:solidFill>
+          <a:ln w="12700">
+            <a:solidFill>
+              <a:srgbClr val="F59E0B"/>
+            </a:solidFill>
+            <a:prstDash val="solid"/>
+          </a:ln>
+        </p:spPr>
+      </p:sp>
+      <p:sp>
+        <p:nvSpPr>
+          <p:cNvPr id="7" name="Text 4"/>
+          <p:cNvSpPr/>
+          <p:nvPr/>
+        </p:nvSpPr>
+        <p:spPr>
+          <a:xfrm>
+            <a:off x="777240" y="2651760"/>
+            <a:ext cx="10637215" cy="914400"/>
+          </a:xfrm>
+          <a:prstGeom prst="rect">
+            <a:avLst/>
+          </a:prstGeom>
+          <a:noFill/>
+          <a:ln/>
+        </p:spPr>
+        <p:txBody>
+          <a:bodyPr wrap="square" lIns="0" tIns="0" rIns="0" bIns="0" rtlCol="0" anchor="ctr"/>
+          <a:lstStyle/>
+          <a:p>
+            <a:pPr algn="l" indent="0" marL="0">
+              <a:lnSpc>
+                <a:spcPct val="115000"/>
+              </a:lnSpc>
+              <a:buNone/>
+            </a:pPr>
+            <a:r>
+              <a:rPr lang="en-US" sz="1300" b="1" dirty="0">
+                <a:solidFill>
+                  <a:srgbClr val="FBBF24"/>
+                </a:solidFill>
+                <a:latin typeface="Calibri" pitchFamily="34" charset="0"/>
+                <a:ea typeface="Calibri" pitchFamily="34" charset="-122"/>
+                <a:cs typeface="Calibri" pitchFamily="34" charset="-120"/>
+              </a:rPr>
+              <a:t>⚠ Fíjense en g(x). Si g(x)=0, la ecuación es homogénea; si no, es no homogénea. Ojo: esto NO es la 'homogénea' de la Sesión 7 (dy/dx=f(y/x), y=vx) — dos ideas sin relación que comparten nombre.</a:t>
+            </a:r>
+            <a:endParaRPr lang="en-US" sz="1300" dirty="0"/>
+          </a:p>
+        </p:txBody>
+      </p:sp>
+      <p:sp>
+        <p:nvSpPr>
+          <p:cNvPr id="8" name="Shape 5"/>
+          <p:cNvSpPr/>
+          <p:nvPr/>
+        </p:nvSpPr>
+        <p:spPr>
+          <a:xfrm>
+            <a:off x="548640" y="3657600"/>
+            <a:ext cx="11094415" cy="960120"/>
+          </a:xfrm>
+          <a:prstGeom prst="roundRect">
+            <a:avLst>
+              <a:gd name="adj" fmla="val 9524"/>
             </a:avLst>
           </a:prstGeom>
           <a:solidFill>
@@ -6208,7 +6277,7 @@
       </p:sp>
       <p:pic>
         <p:nvPicPr>
-          <p:cNvPr id="7" name="Image 1" descr="build/eq/pvi_conditions.png">    </p:cNvPr>
+          <p:cNvPr id="9" name="Image 1" descr="build/eq/pvi_conditions.png">    </p:cNvPr>
           <p:cNvPicPr>
             <a:picLocks noChangeAspect="1"/>
           </p:cNvPicPr>
@@ -6222,8 +6291,8 @@
         </p:blipFill>
         <p:spPr>
           <a:xfrm>
-            <a:off x="822960" y="3045818"/>
-            <a:ext cx="10545775" cy="720645"/>
+            <a:off x="1077917" y="3794760"/>
+            <a:ext cx="10035862" cy="685800"/>
           </a:xfrm>
           <a:prstGeom prst="rect">
             <a:avLst/>
@@ -6232,14 +6301,14 @@
       </p:pic>
       <p:sp>
         <p:nvSpPr>
-          <p:cNvPr id="8" name="Text 4"/>
-          <p:cNvSpPr/>
-          <p:nvPr/>
-        </p:nvSpPr>
-        <p:spPr>
-          <a:xfrm>
-            <a:off x="548640" y="4160520"/>
-            <a:ext cx="11094415" cy="822960"/>
+          <p:cNvPr id="10" name="Text 6"/>
+          <p:cNvSpPr/>
+          <p:nvPr/>
+        </p:nvSpPr>
+        <p:spPr>
+          <a:xfrm>
+            <a:off x="548640" y="4709160"/>
+            <a:ext cx="11094415" cy="685800"/>
           </a:xfrm>
           <a:prstGeom prst="rect">
             <a:avLst/>
@@ -6258,7 +6327,7 @@
               <a:buNone/>
             </a:pPr>
             <a:r>
-              <a:rPr lang="en-US" sz="1450" dirty="0">
+              <a:rPr lang="en-US" sz="1400" dirty="0">
                 <a:solidFill>
                   <a:srgbClr val="CBD5E1"/>
                 </a:solidFill>
@@ -6268,19 +6337,19 @@
               </a:rPr>
               <a:t>Necesitan una condición por cada derivada, hasta la (n−1)-ésima, todas evaluadas en el mismo punto x₀. Para segundo orden: posición y velocidad iniciales. Para tercer orden, agregan la aceleración inicial.</a:t>
             </a:r>
-            <a:endParaRPr lang="en-US" sz="1450" dirty="0"/>
-          </a:p>
-        </p:txBody>
-      </p:sp>
-      <p:sp>
-        <p:nvSpPr>
-          <p:cNvPr id="9" name="Shape 5"/>
-          <p:cNvSpPr/>
-          <p:nvPr/>
-        </p:nvSpPr>
-        <p:spPr>
-          <a:xfrm>
-            <a:off x="548640" y="5074920"/>
+            <a:endParaRPr lang="en-US" sz="1400" dirty="0"/>
+          </a:p>
+        </p:txBody>
+      </p:sp>
+      <p:sp>
+        <p:nvSpPr>
+          <p:cNvPr id="11" name="Shape 7"/>
+          <p:cNvSpPr/>
+          <p:nvPr/>
+        </p:nvSpPr>
+        <p:spPr>
+          <a:xfrm>
+            <a:off x="548640" y="5486400"/>
             <a:ext cx="11094415" cy="566928"/>
           </a:xfrm>
           <a:prstGeom prst="roundRect">
@@ -6301,13 +6370,13 @@
       </p:sp>
       <p:sp>
         <p:nvSpPr>
-          <p:cNvPr id="10" name="Text 6"/>
-          <p:cNvSpPr/>
-          <p:nvPr/>
-        </p:nvSpPr>
-        <p:spPr>
-          <a:xfrm>
-            <a:off x="777240" y="5074920"/>
+          <p:cNvPr id="12" name="Text 8"/>
+          <p:cNvSpPr/>
+          <p:nvPr/>
+        </p:nvSpPr>
+        <p:spPr>
+          <a:xfrm>
+            <a:off x="777240" y="5486400"/>
             <a:ext cx="10637215" cy="566928"/>
           </a:xfrm>
           <a:prstGeom prst="rect">
@@ -6327,7 +6396,7 @@
               <a:buNone/>
             </a:pPr>
             <a:r>
-              <a:rPr lang="en-US" sz="1350" b="1" dirty="0">
+              <a:rPr lang="en-US" sz="1300" b="1" dirty="0">
                 <a:solidFill>
                   <a:srgbClr val="34D399"/>
                 </a:solidFill>
@@ -6337,13 +6406,13 @@
               </a:rPr>
               <a:t>Ingenieros: cuenten las condiciones antes de empezar — si les faltan o les sobran, algo está mal planteado.</a:t>
             </a:r>
-            <a:endParaRPr lang="en-US" sz="1350" dirty="0"/>
-          </a:p>
-        </p:txBody>
-      </p:sp>
-      <p:sp>
-        <p:nvSpPr>
-          <p:cNvPr id="11" name="Text 7"/>
+            <a:endParaRPr lang="en-US" sz="1300" dirty="0"/>
+          </a:p>
+        </p:txBody>
+      </p:sp>
+      <p:sp>
+        <p:nvSpPr>
+          <p:cNvPr id="13" name="Text 9"/>
           <p:cNvSpPr/>
           <p:nvPr/>
         </p:nvSpPr>
@@ -6382,7 +6451,7 @@
       </p:sp>
       <p:sp>
         <p:nvSpPr>
-          <p:cNvPr id="12" name="Text 8"/>
+          <p:cNvPr id="14" name="Text 10"/>
           <p:cNvSpPr/>
           <p:nvPr/>
         </p:nvSpPr>
@@ -8048,80 +8117,11 @@
         <p:spPr>
           <a:xfrm>
             <a:off x="548640" y="1691640"/>
-            <a:ext cx="11094415" cy="960120"/>
+            <a:ext cx="11094415" cy="1371600"/>
           </a:xfrm>
           <a:prstGeom prst="roundRect">
             <a:avLst>
-              <a:gd name="adj" fmla="val 7619"/>
-            </a:avLst>
-          </a:prstGeom>
-          <a:solidFill>
-            <a:srgbClr val="3A2A0E"/>
-          </a:solidFill>
-          <a:ln w="12700">
-            <a:solidFill>
-              <a:srgbClr val="F59E0B"/>
-            </a:solidFill>
-            <a:prstDash val="solid"/>
-          </a:ln>
-        </p:spPr>
-      </p:sp>
-      <p:sp>
-        <p:nvSpPr>
-          <p:cNvPr id="5" name="Text 3"/>
-          <p:cNvSpPr/>
-          <p:nvPr/>
-        </p:nvSpPr>
-        <p:spPr>
-          <a:xfrm>
-            <a:off x="777240" y="1691640"/>
-            <a:ext cx="10637215" cy="960120"/>
-          </a:xfrm>
-          <a:prstGeom prst="rect">
-            <a:avLst/>
-          </a:prstGeom>
-          <a:noFill/>
-          <a:ln/>
-        </p:spPr>
-        <p:txBody>
-          <a:bodyPr wrap="square" lIns="0" tIns="0" rIns="0" bIns="0" rtlCol="0" anchor="ctr"/>
-          <a:lstStyle/>
-          <a:p>
-            <a:pPr algn="l" indent="0" marL="0">
-              <a:lnSpc>
-                <a:spcPct val="115000"/>
-              </a:lnSpc>
-              <a:buNone/>
-            </a:pPr>
-            <a:r>
-              <a:rPr lang="en-US" sz="1350" b="1" dirty="0">
-                <a:solidFill>
-                  <a:srgbClr val="FBBF24"/>
-                </a:solidFill>
-                <a:latin typeface="Calibri" pitchFamily="34" charset="0"/>
-                <a:ea typeface="Calibri" pitchFamily="34" charset="-122"/>
-                <a:cs typeface="Calibri" pitchFamily="34" charset="-120"/>
-              </a:rPr>
-              <a:t>⚠ 'Homogénea' cambia de significado aquí. En la Sesión 7 era dy/dx=f(y/x), resuelta con y=vx. Desde ahora significa g(x)=0 — el lado derecho es cero. Dos ideas distintas, mismo nombre: no las confundan.</a:t>
-            </a:r>
-            <a:endParaRPr lang="en-US" sz="1350" dirty="0"/>
-          </a:p>
-        </p:txBody>
-      </p:sp>
-      <p:sp>
-        <p:nvSpPr>
-          <p:cNvPr id="6" name="Shape 4"/>
-          <p:cNvSpPr/>
-          <p:nvPr/>
-        </p:nvSpPr>
-        <p:spPr>
-          <a:xfrm>
-            <a:off x="548640" y="2788920"/>
-            <a:ext cx="11094415" cy="1097280"/>
-          </a:xfrm>
-          <a:prstGeom prst="roundRect">
-            <a:avLst>
-              <a:gd name="adj" fmla="val 6667"/>
+              <a:gd name="adj" fmla="val 5333"/>
             </a:avLst>
           </a:prstGeom>
           <a:solidFill>
@@ -8137,7 +8137,7 @@
       </p:sp>
       <p:pic>
         <p:nvPicPr>
-          <p:cNvPr id="7" name="Image 0" descr="build/eq/superposition_homog.png">    </p:cNvPr>
+          <p:cNvPr id="5" name="Image 0" descr="build/eq/superposition_homog.png">    </p:cNvPr>
           <p:cNvPicPr>
             <a:picLocks noChangeAspect="1"/>
           </p:cNvPicPr>
@@ -8151,8 +8151,8 @@
         </p:blipFill>
         <p:spPr>
           <a:xfrm>
-            <a:off x="1861935" y="2926080"/>
-            <a:ext cx="8467825" cy="822960"/>
+            <a:off x="822960" y="1864985"/>
+            <a:ext cx="10545775" cy="1024909"/>
           </a:xfrm>
           <a:prstGeom prst="rect">
             <a:avLst/>
@@ -8161,14 +8161,14 @@
       </p:pic>
       <p:sp>
         <p:nvSpPr>
-          <p:cNvPr id="8" name="Text 5"/>
-          <p:cNvSpPr/>
-          <p:nvPr/>
-        </p:nvSpPr>
-        <p:spPr>
-          <a:xfrm>
-            <a:off x="548640" y="4023360"/>
-            <a:ext cx="11094415" cy="731520"/>
+          <p:cNvPr id="6" name="Text 3"/>
+          <p:cNvSpPr/>
+          <p:nvPr/>
+        </p:nvSpPr>
+        <p:spPr>
+          <a:xfrm>
+            <a:off x="548640" y="3337560"/>
+            <a:ext cx="11094415" cy="822960"/>
           </a:xfrm>
           <a:prstGeom prst="rect">
             <a:avLst/>
@@ -8187,7 +8187,7 @@
               <a:buNone/>
             </a:pPr>
             <a:r>
-              <a:rPr lang="en-US" sz="1450" dirty="0">
+              <a:rPr lang="en-US" sz="1500" dirty="0">
                 <a:solidFill>
                   <a:srgbClr val="CBD5E1"/>
                 </a:solidFill>
@@ -8195,26 +8195,26 @@
                 <a:ea typeface="Calibri" pitchFamily="34" charset="-122"/>
                 <a:cs typeface="Calibri" pitchFamily="34" charset="-120"/>
               </a:rPr>
-              <a:t>Si y₁, y₂, …, yₖ son soluciones de la MISMA ecuación homogénea (en este nuevo sentido), entonces cualquier combinación lineal de ellas también es solución. Pueden verificarlo sustituyendo directamente.</a:t>
-            </a:r>
-            <a:endParaRPr lang="en-US" sz="1450" dirty="0"/>
-          </a:p>
-        </p:txBody>
-      </p:sp>
-      <p:sp>
-        <p:nvSpPr>
-          <p:cNvPr id="9" name="Shape 6"/>
-          <p:cNvSpPr/>
-          <p:nvPr/>
-        </p:nvSpPr>
-        <p:spPr>
-          <a:xfrm>
-            <a:off x="548640" y="4892040"/>
-            <a:ext cx="11094415" cy="731520"/>
+              <a:t>Si y₁, y₂, …, yₖ son soluciones de la MISMA ecuación homogénea, entonces cualquier combinación lineal de ellas también es solución. Pueden verificarlo sustituyendo directamente.</a:t>
+            </a:r>
+            <a:endParaRPr lang="en-US" sz="1500" dirty="0"/>
+          </a:p>
+        </p:txBody>
+      </p:sp>
+      <p:sp>
+        <p:nvSpPr>
+          <p:cNvPr id="7" name="Shape 4"/>
+          <p:cNvSpPr/>
+          <p:nvPr/>
+        </p:nvSpPr>
+        <p:spPr>
+          <a:xfrm>
+            <a:off x="548640" y="4343400"/>
+            <a:ext cx="11094415" cy="777240"/>
           </a:xfrm>
           <a:prstGeom prst="roundRect">
             <a:avLst>
-              <a:gd name="adj" fmla="val 10000"/>
+              <a:gd name="adj" fmla="val 9412"/>
             </a:avLst>
           </a:prstGeom>
           <a:solidFill>
@@ -8230,14 +8230,14 @@
       </p:sp>
       <p:sp>
         <p:nvSpPr>
-          <p:cNvPr id="10" name="Text 7"/>
-          <p:cNvSpPr/>
-          <p:nvPr/>
-        </p:nvSpPr>
-        <p:spPr>
-          <a:xfrm>
-            <a:off x="777240" y="4892040"/>
-            <a:ext cx="10637215" cy="731520"/>
+          <p:cNvPr id="8" name="Text 5"/>
+          <p:cNvSpPr/>
+          <p:nvPr/>
+        </p:nvSpPr>
+        <p:spPr>
+          <a:xfrm>
+            <a:off x="777240" y="4343400"/>
+            <a:ext cx="10637215" cy="777240"/>
           </a:xfrm>
           <a:prstGeom prst="rect">
             <a:avLst/>
@@ -8256,7 +8256,7 @@
               <a:buNone/>
             </a:pPr>
             <a:r>
-              <a:rPr lang="en-US" sz="1350" b="1" dirty="0">
+              <a:rPr lang="en-US" sz="1400" b="1" dirty="0">
                 <a:solidFill>
                   <a:srgbClr val="34D399"/>
                 </a:solidFill>
@@ -8266,13 +8266,13 @@
               </a:rPr>
               <a:t>Esta es la razón por la que, en la Sesión 10, nunca vamos a buscar 'la' solución — vamos a buscar varias soluciones simples y combinarlas.</a:t>
             </a:r>
-            <a:endParaRPr lang="en-US" sz="1350" dirty="0"/>
-          </a:p>
-        </p:txBody>
-      </p:sp>
-      <p:sp>
-        <p:nvSpPr>
-          <p:cNvPr id="11" name="Text 8"/>
+            <a:endParaRPr lang="en-US" sz="1400" dirty="0"/>
+          </a:p>
+        </p:txBody>
+      </p:sp>
+      <p:sp>
+        <p:nvSpPr>
+          <p:cNvPr id="9" name="Text 6"/>
           <p:cNvSpPr/>
           <p:nvPr/>
         </p:nvSpPr>
@@ -8311,7 +8311,7 @@
       </p:sp>
       <p:sp>
         <p:nvSpPr>
-          <p:cNvPr id="12" name="Text 9"/>
+          <p:cNvPr id="10" name="Text 7"/>
           <p:cNvSpPr/>
           <p:nvPr/>
         </p:nvSpPr>

</xml_diff>